<commit_message>
Updated Professional Networking Service Deliverables
</commit_message>
<xml_diff>
--- a/docs/2_Value_Creation/2a_Product/Professional_Networking/Professional_Networking_v1_Deliverables_Overview.pptx
+++ b/docs/2_Value_Creation/2a_Product/Professional_Networking/Professional_Networking_v1_Deliverables_Overview.pptx
@@ -266,7 +266,7 @@
 <file path=ppt/revisionInfo.xml><?xml version="1.0" encoding="utf-8"?>
 <p1510:revInfo xmlns:a="http://schemas.openxmlformats.org/drawingml/2006/main" xmlns:r="http://schemas.openxmlformats.org/officeDocument/2006/relationships" xmlns:p1510="http://schemas.microsoft.com/office/powerpoint/2015/10/main">
   <p1510:revLst>
-    <p1510:client id="{D0AB143F-4C99-C24B-ABCA-9A1BBADA0156}" v="3" dt="2026-08-09T19:39:54.762"/>
+    <p1510:client id="{D0AB143F-4C99-C24B-ABCA-9A1BBADA0156}" v="12" dt="2026-08-12T12:26:36.659"/>
   </p1510:revLst>
 </p1510:revInfo>
 </file>
@@ -276,18 +276,18 @@
   <pc:docChgLst>
     <pc:chgData name="Rich Reba" userId="55db41ab6eb3f845" providerId="LiveId" clId="{0E19DA16-244C-5B50-BE0F-52911DD4CA7E}"/>
     <pc:docChg chg="undo custSel addSld delSld modSld">
-      <pc:chgData name="Rich Reba" userId="55db41ab6eb3f845" providerId="LiveId" clId="{0E19DA16-244C-5B50-BE0F-52911DD4CA7E}" dt="2026-08-12T12:15:41.277" v="895" actId="2696"/>
+      <pc:chgData name="Rich Reba" userId="55db41ab6eb3f845" providerId="LiveId" clId="{0E19DA16-244C-5B50-BE0F-52911DD4CA7E}" dt="2026-08-12T12:27:48.702" v="919" actId="20577"/>
       <pc:docMkLst>
         <pc:docMk/>
       </pc:docMkLst>
       <pc:sldChg chg="modSp mod">
-        <pc:chgData name="Rich Reba" userId="55db41ab6eb3f845" providerId="LiveId" clId="{0E19DA16-244C-5B50-BE0F-52911DD4CA7E}" dt="2026-08-09T19:25:47.601" v="718" actId="20577"/>
+        <pc:chgData name="Rich Reba" userId="55db41ab6eb3f845" providerId="LiveId" clId="{0E19DA16-244C-5B50-BE0F-52911DD4CA7E}" dt="2026-08-12T12:27:48.702" v="919" actId="20577"/>
         <pc:sldMkLst>
           <pc:docMk/>
           <pc:sldMk cId="0" sldId="256"/>
         </pc:sldMkLst>
         <pc:spChg chg="mod">
-          <ac:chgData name="Rich Reba" userId="55db41ab6eb3f845" providerId="LiveId" clId="{0E19DA16-244C-5B50-BE0F-52911DD4CA7E}" dt="2026-08-09T19:25:47.601" v="718" actId="20577"/>
+          <ac:chgData name="Rich Reba" userId="55db41ab6eb3f845" providerId="LiveId" clId="{0E19DA16-244C-5B50-BE0F-52911DD4CA7E}" dt="2026-08-12T12:27:48.702" v="919" actId="20577"/>
           <ac:spMkLst>
             <pc:docMk/>
             <pc:sldMk cId="0" sldId="256"/>
@@ -295,12 +295,36 @@
           </ac:spMkLst>
         </pc:spChg>
       </pc:sldChg>
-      <pc:sldChg chg="delSp modSp add del mod">
-        <pc:chgData name="Rich Reba" userId="55db41ab6eb3f845" providerId="LiveId" clId="{0E19DA16-244C-5B50-BE0F-52911DD4CA7E}" dt="2026-08-12T12:15:16.727" v="889" actId="478"/>
+      <pc:sldChg chg="addSp delSp modSp add del mod">
+        <pc:chgData name="Rich Reba" userId="55db41ab6eb3f845" providerId="LiveId" clId="{0E19DA16-244C-5B50-BE0F-52911DD4CA7E}" dt="2026-08-12T12:24:47.601" v="913"/>
         <pc:sldMkLst>
           <pc:docMk/>
           <pc:sldMk cId="1272635936" sldId="264"/>
         </pc:sldMkLst>
+        <pc:spChg chg="add del mod">
+          <ac:chgData name="Rich Reba" userId="55db41ab6eb3f845" providerId="LiveId" clId="{0E19DA16-244C-5B50-BE0F-52911DD4CA7E}" dt="2026-08-12T12:23:55.555" v="898"/>
+          <ac:spMkLst>
+            <pc:docMk/>
+            <pc:sldMk cId="1272635936" sldId="264"/>
+            <ac:spMk id="5" creationId="{EAE634F3-0A78-7D3B-BCC9-7B6CDA6CA4F4}"/>
+          </ac:spMkLst>
+        </pc:spChg>
+        <pc:spChg chg="add del mod">
+          <ac:chgData name="Rich Reba" userId="55db41ab6eb3f845" providerId="LiveId" clId="{0E19DA16-244C-5B50-BE0F-52911DD4CA7E}" dt="2026-08-12T12:24:08.553" v="903" actId="478"/>
+          <ac:spMkLst>
+            <pc:docMk/>
+            <pc:sldMk cId="1272635936" sldId="264"/>
+            <ac:spMk id="7" creationId="{207DC645-441D-D829-9480-23649A22EBD0}"/>
+          </ac:spMkLst>
+        </pc:spChg>
+        <pc:spChg chg="add mod">
+          <ac:chgData name="Rich Reba" userId="55db41ab6eb3f845" providerId="LiveId" clId="{0E19DA16-244C-5B50-BE0F-52911DD4CA7E}" dt="2026-08-12T12:24:47.601" v="913"/>
+          <ac:spMkLst>
+            <pc:docMk/>
+            <pc:sldMk cId="1272635936" sldId="264"/>
+            <ac:spMk id="8" creationId="{1496CFD0-CC3F-65DD-969F-F7DD1397FD8A}"/>
+          </ac:spMkLst>
+        </pc:spChg>
         <pc:graphicFrameChg chg="del modGraphic">
           <ac:chgData name="Rich Reba" userId="55db41ab6eb3f845" providerId="LiveId" clId="{0E19DA16-244C-5B50-BE0F-52911DD4CA7E}" dt="2026-08-12T12:15:16.727" v="889" actId="478"/>
           <ac:graphicFrameMkLst>
@@ -325,12 +349,20 @@
           </ac:graphicFrameMkLst>
         </pc:graphicFrameChg>
       </pc:sldChg>
-      <pc:sldChg chg="delSp modSp mod">
-        <pc:chgData name="Rich Reba" userId="55db41ab6eb3f845" providerId="LiveId" clId="{0E19DA16-244C-5B50-BE0F-52911DD4CA7E}" dt="2026-08-12T12:15:34.987" v="891" actId="478"/>
+      <pc:sldChg chg="addSp delSp modSp mod">
+        <pc:chgData name="Rich Reba" userId="55db41ab6eb3f845" providerId="LiveId" clId="{0E19DA16-244C-5B50-BE0F-52911DD4CA7E}" dt="2026-08-12T12:25:55.429" v="916" actId="3626"/>
         <pc:sldMkLst>
           <pc:docMk/>
           <pc:sldMk cId="1243007551" sldId="268"/>
         </pc:sldMkLst>
+        <pc:spChg chg="add mod">
+          <ac:chgData name="Rich Reba" userId="55db41ab6eb3f845" providerId="LiveId" clId="{0E19DA16-244C-5B50-BE0F-52911DD4CA7E}" dt="2026-08-12T12:25:55.429" v="916" actId="3626"/>
+          <ac:spMkLst>
+            <pc:docMk/>
+            <pc:sldMk cId="1243007551" sldId="268"/>
+            <ac:spMk id="2" creationId="{9A67326E-FBC5-950B-3C9B-6545AE647EDF}"/>
+          </ac:spMkLst>
+        </pc:spChg>
         <pc:spChg chg="mod">
           <ac:chgData name="Rich Reba" userId="55db41ab6eb3f845" providerId="LiveId" clId="{0E19DA16-244C-5B50-BE0F-52911DD4CA7E}" dt="2026-08-12T12:15:30.623" v="890" actId="20577"/>
           <ac:spMkLst>
@@ -354,14 +386,6 @@
           <pc:docMk/>
           <pc:sldMk cId="450257364" sldId="269"/>
         </pc:sldMkLst>
-        <pc:graphicFrameChg chg="modGraphic">
-          <ac:chgData name="Rich Reba" userId="55db41ab6eb3f845" providerId="LiveId" clId="{0E19DA16-244C-5B50-BE0F-52911DD4CA7E}" dt="2026-08-09T19:18:38.979" v="405" actId="20577"/>
-          <ac:graphicFrameMkLst>
-            <pc:docMk/>
-            <pc:sldMk cId="450257364" sldId="269"/>
-            <ac:graphicFrameMk id="2" creationId="{849548E0-A616-4177-21C8-C63119ADCD53}"/>
-          </ac:graphicFrameMkLst>
-        </pc:graphicFrameChg>
       </pc:sldChg>
       <pc:sldChg chg="modSp del mod">
         <pc:chgData name="Rich Reba" userId="55db41ab6eb3f845" providerId="LiveId" clId="{0E19DA16-244C-5B50-BE0F-52911DD4CA7E}" dt="2026-08-12T12:15:37.368" v="893" actId="2696"/>
@@ -369,14 +393,6 @@
           <pc:docMk/>
           <pc:sldMk cId="4255637138" sldId="270"/>
         </pc:sldMkLst>
-        <pc:graphicFrameChg chg="modGraphic">
-          <ac:chgData name="Rich Reba" userId="55db41ab6eb3f845" providerId="LiveId" clId="{0E19DA16-244C-5B50-BE0F-52911DD4CA7E}" dt="2026-08-09T19:21:32.870" v="556" actId="20577"/>
-          <ac:graphicFrameMkLst>
-            <pc:docMk/>
-            <pc:sldMk cId="4255637138" sldId="270"/>
-            <ac:graphicFrameMk id="3" creationId="{14B79CD4-17D9-A460-45EE-070B6CD3DAFF}"/>
-          </ac:graphicFrameMkLst>
-        </pc:graphicFrameChg>
       </pc:sldChg>
       <pc:sldChg chg="modSp del mod">
         <pc:chgData name="Rich Reba" userId="55db41ab6eb3f845" providerId="LiveId" clId="{0E19DA16-244C-5B50-BE0F-52911DD4CA7E}" dt="2026-08-12T12:15:37.861" v="894" actId="2696"/>
@@ -384,14 +400,6 @@
           <pc:docMk/>
           <pc:sldMk cId="67448461" sldId="271"/>
         </pc:sldMkLst>
-        <pc:graphicFrameChg chg="modGraphic">
-          <ac:chgData name="Rich Reba" userId="55db41ab6eb3f845" providerId="LiveId" clId="{0E19DA16-244C-5B50-BE0F-52911DD4CA7E}" dt="2026-08-09T19:24:10.574" v="667" actId="20577"/>
-          <ac:graphicFrameMkLst>
-            <pc:docMk/>
-            <pc:sldMk cId="67448461" sldId="271"/>
-            <ac:graphicFrameMk id="2" creationId="{59DCEAC8-DB72-C8D9-0DB4-F8D83D801ADB}"/>
-          </ac:graphicFrameMkLst>
-        </pc:graphicFrameChg>
       </pc:sldChg>
       <pc:sldChg chg="modSp del mod">
         <pc:chgData name="Rich Reba" userId="55db41ab6eb3f845" providerId="LiveId" clId="{0E19DA16-244C-5B50-BE0F-52911DD4CA7E}" dt="2026-08-12T12:15:41.277" v="895" actId="2696"/>
@@ -407,14 +415,6 @@
             <ac:spMk id="96" creationId="{00000000-0000-0000-0000-000000000000}"/>
           </ac:spMkLst>
         </pc:spChg>
-        <pc:graphicFrameChg chg="modGraphic">
-          <ac:chgData name="Rich Reba" userId="55db41ab6eb3f845" providerId="LiveId" clId="{0E19DA16-244C-5B50-BE0F-52911DD4CA7E}" dt="2026-08-09T19:24:21.846" v="679" actId="20577"/>
-          <ac:graphicFrameMkLst>
-            <pc:docMk/>
-            <pc:sldMk cId="3088802820" sldId="272"/>
-            <ac:graphicFrameMk id="3" creationId="{F1699409-9005-50C8-4771-BC86CF9F9048}"/>
-          </ac:graphicFrameMkLst>
-        </pc:graphicFrameChg>
       </pc:sldChg>
       <pc:sldChg chg="modSp">
         <pc:chgData name="Rich Reba" userId="55db41ab6eb3f845" providerId="LiveId" clId="{0E19DA16-244C-5B50-BE0F-52911DD4CA7E}" dt="2026-08-09T19:39:54.762" v="885"/>
@@ -15604,7 +15604,7 @@
             </a:pPr>
             <a:r>
               <a:rPr lang="en-US" dirty="0"/>
-              <a:t>August 9, 2026</a:t>
+              <a:t>August 12, 2026</a:t>
             </a:r>
           </a:p>
         </p:txBody>
@@ -17973,6 +17973,44 @@
               <a:t>Proprietary and Confidential Information</a:t>
             </a:r>
             <a:endParaRPr dirty="0"/>
+          </a:p>
+        </p:txBody>
+      </p:sp>
+      <p:sp>
+        <p:nvSpPr>
+          <p:cNvPr id="8" name="TextBox 7">
+            <a:extLst>
+              <a:ext uri="{FF2B5EF4-FFF2-40B4-BE49-F238E27FC236}">
+                <a16:creationId xmlns:a16="http://schemas.microsoft.com/office/drawing/2014/main" id="{1496CFD0-CC3F-65DD-969F-F7DD1397FD8A}"/>
+              </a:ext>
+            </a:extLst>
+          </p:cNvPr>
+          <p:cNvSpPr txBox="1"/>
+          <p:nvPr/>
+        </p:nvSpPr>
+        <p:spPr>
+          <a:xfrm>
+            <a:off x="914400" y="1883229"/>
+            <a:ext cx="5301451" cy="307777"/>
+          </a:xfrm>
+          <a:prstGeom prst="rect">
+            <a:avLst/>
+          </a:prstGeom>
+          <a:noFill/>
+        </p:spPr>
+        <p:txBody>
+          <a:bodyPr wrap="none" rtlCol="0">
+            <a:spAutoFit/>
+          </a:bodyPr>
+          <a:lstStyle/>
+          <a:p>
+            <a:r>
+              <a:rPr lang="en-US" dirty="0">
+                <a:hlinkClick r:id="rId3"/>
+              </a:rPr>
+              <a:t>Link to Professional_Networking_v1_Epic-Hypothesis-Statement</a:t>
+            </a:r>
+            <a:endParaRPr lang="en-US" dirty="0"/>
           </a:p>
         </p:txBody>
       </p:sp>
@@ -21770,6 +21808,44 @@
               <a:t>Proprietary and Confidential Information</a:t>
             </a:r>
             <a:endParaRPr dirty="0"/>
+          </a:p>
+        </p:txBody>
+      </p:sp>
+      <p:sp>
+        <p:nvSpPr>
+          <p:cNvPr id="2" name="TextBox 1">
+            <a:extLst>
+              <a:ext uri="{FF2B5EF4-FFF2-40B4-BE49-F238E27FC236}">
+                <a16:creationId xmlns:a16="http://schemas.microsoft.com/office/drawing/2014/main" id="{9A67326E-FBC5-950B-3C9B-6545AE647EDF}"/>
+              </a:ext>
+            </a:extLst>
+          </p:cNvPr>
+          <p:cNvSpPr txBox="1"/>
+          <p:nvPr/>
+        </p:nvSpPr>
+        <p:spPr>
+          <a:xfrm>
+            <a:off x="914400" y="1883229"/>
+            <a:ext cx="4873450" cy="307777"/>
+          </a:xfrm>
+          <a:prstGeom prst="rect">
+            <a:avLst/>
+          </a:prstGeom>
+          <a:noFill/>
+        </p:spPr>
+        <p:txBody>
+          <a:bodyPr wrap="none" rtlCol="0">
+            <a:spAutoFit/>
+          </a:bodyPr>
+          <a:lstStyle/>
+          <a:p>
+            <a:r>
+              <a:rPr lang="en-US" dirty="0">
+                <a:hlinkClick r:id="rId3"/>
+              </a:rPr>
+              <a:t>Link to Professional_Networking_v1_Lean_Business_Case</a:t>
+            </a:r>
+            <a:endParaRPr lang="en-US" dirty="0"/>
           </a:p>
         </p:txBody>
       </p:sp>

</xml_diff>

<commit_message>
Improved Product Repository - Professional Networking v1 Deliverables
</commit_message>
<xml_diff>
--- a/docs/2_Value_Creation/2a_Product/Professional_Networking/Professional_Networking_v1_Deliverables_Overview.pptx
+++ b/docs/2_Value_Creation/2a_Product/Professional_Networking/Professional_Networking_v1_Deliverables_Overview.pptx
@@ -257,7 +257,7 @@
       <p15:sldGuideLst xmlns:p15="http://schemas.microsoft.com/office/powerpoint/2012/main"/>
     </p:ext>
     <p:ext uri="GoogleSlidesCustomDataVersion2">
-      <go:slidesCustomData xmlns="" xmlns:mc="http://schemas.openxmlformats.org/markup-compatibility/2006" xmlns:mv="urn:schemas-microsoft-com:mac:vml" xmlns:c="http://schemas.openxmlformats.org/drawingml/2006/chart" xmlns:dgm="http://schemas.openxmlformats.org/drawingml/2006/diagram" xmlns:o="urn:schemas-microsoft-com:office:office" xmlns:v="urn:schemas-microsoft-com:vml" xmlns:pvml="urn:schemas-microsoft-com:office:powerpoint" xmlns:com="http://schemas.openxmlformats.org/drawingml/2006/compatibility" xmlns:p14="http://schemas.microsoft.com/office/powerpoint/2010/main" xmlns:p15="http://schemas.microsoft.com/office/powerpoint/2012/main" xmlns:ahyp="http://schemas.microsoft.com/office/drawing/2018/hyperlinkcolor" xmlns:go="http://customooxmlschemas.google.com/" r:id="rId19" roundtripDataSignature="AMtx7mhwEp+Eio5qReXqYqUwMP31HB0A8A=="/>
+      <go:slidesCustomData xmlns:go="http://customooxmlschemas.google.com/" xmlns:ahyp="http://schemas.microsoft.com/office/drawing/2018/hyperlinkcolor" xmlns:p15="http://schemas.microsoft.com/office/powerpoint/2012/main" xmlns:p14="http://schemas.microsoft.com/office/powerpoint/2010/main" xmlns:com="http://schemas.openxmlformats.org/drawingml/2006/compatibility" xmlns:pvml="urn:schemas-microsoft-com:office:powerpoint" xmlns:v="urn:schemas-microsoft-com:vml" xmlns:o="urn:schemas-microsoft-com:office:office" xmlns:dgm="http://schemas.openxmlformats.org/drawingml/2006/diagram" xmlns:c="http://schemas.openxmlformats.org/drawingml/2006/chart" xmlns:mv="urn:schemas-microsoft-com:mac:vml" xmlns:mc="http://schemas.openxmlformats.org/markup-compatibility/2006" xmlns="" r:id="rId19" roundtripDataSignature="AMtx7mhwEp+Eio5qReXqYqUwMP31HB0A8A=="/>
     </p:ext>
   </p:extLst>
 </p:presentation>
@@ -266,7 +266,7 @@
 <file path=ppt/revisionInfo.xml><?xml version="1.0" encoding="utf-8"?>
 <p1510:revInfo xmlns:a="http://schemas.openxmlformats.org/drawingml/2006/main" xmlns:r="http://schemas.openxmlformats.org/officeDocument/2006/relationships" xmlns:p1510="http://schemas.microsoft.com/office/powerpoint/2015/10/main">
   <p1510:revLst>
-    <p1510:client id="{D0AB143F-4C99-C24B-ABCA-9A1BBADA0156}" v="12" dt="2026-08-12T12:26:36.659"/>
+    <p1510:client id="{D0AB143F-4C99-C24B-ABCA-9A1BBADA0156}" v="13" dt="2026-08-14T16:48:34.631"/>
   </p1510:revLst>
 </p1510:revInfo>
 </file>
@@ -276,18 +276,26 @@
   <pc:docChgLst>
     <pc:chgData name="Rich Reba" userId="55db41ab6eb3f845" providerId="LiveId" clId="{0E19DA16-244C-5B50-BE0F-52911DD4CA7E}"/>
     <pc:docChg chg="undo custSel addSld delSld modSld">
-      <pc:chgData name="Rich Reba" userId="55db41ab6eb3f845" providerId="LiveId" clId="{0E19DA16-244C-5B50-BE0F-52911DD4CA7E}" dt="2026-08-12T12:27:48.702" v="919" actId="20577"/>
+      <pc:chgData name="Rich Reba" userId="55db41ab6eb3f845" providerId="LiveId" clId="{0E19DA16-244C-5B50-BE0F-52911DD4CA7E}" dt="2026-08-14T16:48:51.159" v="932" actId="20577"/>
       <pc:docMkLst>
         <pc:docMk/>
       </pc:docMkLst>
-      <pc:sldChg chg="modSp mod">
-        <pc:chgData name="Rich Reba" userId="55db41ab6eb3f845" providerId="LiveId" clId="{0E19DA16-244C-5B50-BE0F-52911DD4CA7E}" dt="2026-08-12T12:27:48.702" v="919" actId="20577"/>
+      <pc:sldChg chg="delSp modSp mod">
+        <pc:chgData name="Rich Reba" userId="55db41ab6eb3f845" providerId="LiveId" clId="{0E19DA16-244C-5B50-BE0F-52911DD4CA7E}" dt="2026-08-14T16:48:51.159" v="932" actId="20577"/>
         <pc:sldMkLst>
           <pc:docMk/>
           <pc:sldMk cId="0" sldId="256"/>
         </pc:sldMkLst>
+        <pc:spChg chg="del">
+          <ac:chgData name="Rich Reba" userId="55db41ab6eb3f845" providerId="LiveId" clId="{0E19DA16-244C-5B50-BE0F-52911DD4CA7E}" dt="2026-08-14T16:47:41.495" v="920" actId="478"/>
+          <ac:spMkLst>
+            <pc:docMk/>
+            <pc:sldMk cId="0" sldId="256"/>
+            <ac:spMk id="2" creationId="{B78BEAA4-CC48-1EF1-1035-C48CDEB46C11}"/>
+          </ac:spMkLst>
+        </pc:spChg>
         <pc:spChg chg="mod">
-          <ac:chgData name="Rich Reba" userId="55db41ab6eb3f845" providerId="LiveId" clId="{0E19DA16-244C-5B50-BE0F-52911DD4CA7E}" dt="2026-08-12T12:27:48.702" v="919" actId="20577"/>
+          <ac:chgData name="Rich Reba" userId="55db41ab6eb3f845" providerId="LiveId" clId="{0E19DA16-244C-5B50-BE0F-52911DD4CA7E}" dt="2026-08-14T16:48:51.159" v="932" actId="20577"/>
           <ac:spMkLst>
             <pc:docMk/>
             <pc:sldMk cId="0" sldId="256"/>
@@ -296,25 +304,17 @@
         </pc:spChg>
       </pc:sldChg>
       <pc:sldChg chg="addSp delSp modSp add del mod">
-        <pc:chgData name="Rich Reba" userId="55db41ab6eb3f845" providerId="LiveId" clId="{0E19DA16-244C-5B50-BE0F-52911DD4CA7E}" dt="2026-08-12T12:24:47.601" v="913"/>
+        <pc:chgData name="Rich Reba" userId="55db41ab6eb3f845" providerId="LiveId" clId="{0E19DA16-244C-5B50-BE0F-52911DD4CA7E}" dt="2026-08-14T16:47:49.303" v="922" actId="478"/>
         <pc:sldMkLst>
           <pc:docMk/>
           <pc:sldMk cId="1272635936" sldId="264"/>
         </pc:sldMkLst>
-        <pc:spChg chg="add del mod">
-          <ac:chgData name="Rich Reba" userId="55db41ab6eb3f845" providerId="LiveId" clId="{0E19DA16-244C-5B50-BE0F-52911DD4CA7E}" dt="2026-08-12T12:23:55.555" v="898"/>
+        <pc:spChg chg="del">
+          <ac:chgData name="Rich Reba" userId="55db41ab6eb3f845" providerId="LiveId" clId="{0E19DA16-244C-5B50-BE0F-52911DD4CA7E}" dt="2026-08-14T16:47:49.303" v="922" actId="478"/>
           <ac:spMkLst>
             <pc:docMk/>
             <pc:sldMk cId="1272635936" sldId="264"/>
-            <ac:spMk id="5" creationId="{EAE634F3-0A78-7D3B-BCC9-7B6CDA6CA4F4}"/>
-          </ac:spMkLst>
-        </pc:spChg>
-        <pc:spChg chg="add del mod">
-          <ac:chgData name="Rich Reba" userId="55db41ab6eb3f845" providerId="LiveId" clId="{0E19DA16-244C-5B50-BE0F-52911DD4CA7E}" dt="2026-08-12T12:24:08.553" v="903" actId="478"/>
-          <ac:spMkLst>
-            <pc:docMk/>
-            <pc:sldMk cId="1272635936" sldId="264"/>
-            <ac:spMk id="7" creationId="{207DC645-441D-D829-9480-23649A22EBD0}"/>
+            <ac:spMk id="6" creationId="{F57F7845-FD8A-DCA4-39DB-1B7D9CF0BA2A}"/>
           </ac:spMkLst>
         </pc:spChg>
         <pc:spChg chg="add mod">
@@ -325,21 +325,21 @@
             <ac:spMk id="8" creationId="{1496CFD0-CC3F-65DD-969F-F7DD1397FD8A}"/>
           </ac:spMkLst>
         </pc:spChg>
-        <pc:graphicFrameChg chg="del modGraphic">
-          <ac:chgData name="Rich Reba" userId="55db41ab6eb3f845" providerId="LiveId" clId="{0E19DA16-244C-5B50-BE0F-52911DD4CA7E}" dt="2026-08-12T12:15:16.727" v="889" actId="478"/>
-          <ac:graphicFrameMkLst>
-            <pc:docMk/>
-            <pc:sldMk cId="1272635936" sldId="264"/>
-            <ac:graphicFrameMk id="5" creationId="{4B70F3A5-8062-29A2-30D0-2783CB3DFCCA}"/>
-          </ac:graphicFrameMkLst>
-        </pc:graphicFrameChg>
       </pc:sldChg>
-      <pc:sldChg chg="modSp mod">
-        <pc:chgData name="Rich Reba" userId="55db41ab6eb3f845" providerId="LiveId" clId="{0E19DA16-244C-5B50-BE0F-52911DD4CA7E}" dt="2026-08-09T19:15:26.765" v="158" actId="20577"/>
+      <pc:sldChg chg="delSp modSp mod">
+        <pc:chgData name="Rich Reba" userId="55db41ab6eb3f845" providerId="LiveId" clId="{0E19DA16-244C-5B50-BE0F-52911DD4CA7E}" dt="2026-08-14T16:47:54.312" v="923" actId="478"/>
         <pc:sldMkLst>
           <pc:docMk/>
           <pc:sldMk cId="4188122143" sldId="266"/>
         </pc:sldMkLst>
+        <pc:spChg chg="del">
+          <ac:chgData name="Rich Reba" userId="55db41ab6eb3f845" providerId="LiveId" clId="{0E19DA16-244C-5B50-BE0F-52911DD4CA7E}" dt="2026-08-14T16:47:54.312" v="923" actId="478"/>
+          <ac:spMkLst>
+            <pc:docMk/>
+            <pc:sldMk cId="4188122143" sldId="266"/>
+            <ac:spMk id="5" creationId="{C5748C3E-8A70-958C-B8E4-332FC5861BB3}"/>
+          </ac:spMkLst>
+        </pc:spChg>
         <pc:graphicFrameChg chg="modGraphic">
           <ac:chgData name="Rich Reba" userId="55db41ab6eb3f845" providerId="LiveId" clId="{0E19DA16-244C-5B50-BE0F-52911DD4CA7E}" dt="2026-08-09T19:15:26.765" v="158" actId="20577"/>
           <ac:graphicFrameMkLst>
@@ -350,7 +350,7 @@
         </pc:graphicFrameChg>
       </pc:sldChg>
       <pc:sldChg chg="addSp delSp modSp mod">
-        <pc:chgData name="Rich Reba" userId="55db41ab6eb3f845" providerId="LiveId" clId="{0E19DA16-244C-5B50-BE0F-52911DD4CA7E}" dt="2026-08-12T12:25:55.429" v="916" actId="3626"/>
+        <pc:chgData name="Rich Reba" userId="55db41ab6eb3f845" providerId="LiveId" clId="{0E19DA16-244C-5B50-BE0F-52911DD4CA7E}" dt="2026-08-14T16:48:11.062" v="927" actId="478"/>
         <pc:sldMkLst>
           <pc:docMk/>
           <pc:sldMk cId="1243007551" sldId="268"/>
@@ -363,6 +363,14 @@
             <ac:spMk id="2" creationId="{9A67326E-FBC5-950B-3C9B-6545AE647EDF}"/>
           </ac:spMkLst>
         </pc:spChg>
+        <pc:spChg chg="del">
+          <ac:chgData name="Rich Reba" userId="55db41ab6eb3f845" providerId="LiveId" clId="{0E19DA16-244C-5B50-BE0F-52911DD4CA7E}" dt="2026-08-14T16:48:11.062" v="927" actId="478"/>
+          <ac:spMkLst>
+            <pc:docMk/>
+            <pc:sldMk cId="1243007551" sldId="268"/>
+            <ac:spMk id="6" creationId="{FC3986F6-425A-0514-DE8E-DE31978EAAD1}"/>
+          </ac:spMkLst>
+        </pc:spChg>
         <pc:spChg chg="mod">
           <ac:chgData name="Rich Reba" userId="55db41ab6eb3f845" providerId="LiveId" clId="{0E19DA16-244C-5B50-BE0F-52911DD4CA7E}" dt="2026-08-12T12:15:30.623" v="890" actId="20577"/>
           <ac:spMkLst>
@@ -371,57 +379,21 @@
             <ac:spMk id="96" creationId="{00000000-0000-0000-0000-000000000000}"/>
           </ac:spMkLst>
         </pc:spChg>
-        <pc:graphicFrameChg chg="del modGraphic">
-          <ac:chgData name="Rich Reba" userId="55db41ab6eb3f845" providerId="LiveId" clId="{0E19DA16-244C-5B50-BE0F-52911DD4CA7E}" dt="2026-08-12T12:15:34.987" v="891" actId="478"/>
-          <ac:graphicFrameMkLst>
-            <pc:docMk/>
-            <pc:sldMk cId="1243007551" sldId="268"/>
-            <ac:graphicFrameMk id="2" creationId="{849548E0-A616-4177-21C8-C63119ADCD53}"/>
-          </ac:graphicFrameMkLst>
-        </pc:graphicFrameChg>
       </pc:sldChg>
-      <pc:sldChg chg="modSp del mod">
-        <pc:chgData name="Rich Reba" userId="55db41ab6eb3f845" providerId="LiveId" clId="{0E19DA16-244C-5B50-BE0F-52911DD4CA7E}" dt="2026-08-12T12:15:36.827" v="892" actId="2696"/>
-        <pc:sldMkLst>
-          <pc:docMk/>
-          <pc:sldMk cId="450257364" sldId="269"/>
-        </pc:sldMkLst>
-      </pc:sldChg>
-      <pc:sldChg chg="modSp del mod">
-        <pc:chgData name="Rich Reba" userId="55db41ab6eb3f845" providerId="LiveId" clId="{0E19DA16-244C-5B50-BE0F-52911DD4CA7E}" dt="2026-08-12T12:15:37.368" v="893" actId="2696"/>
-        <pc:sldMkLst>
-          <pc:docMk/>
-          <pc:sldMk cId="4255637138" sldId="270"/>
-        </pc:sldMkLst>
-      </pc:sldChg>
-      <pc:sldChg chg="modSp del mod">
-        <pc:chgData name="Rich Reba" userId="55db41ab6eb3f845" providerId="LiveId" clId="{0E19DA16-244C-5B50-BE0F-52911DD4CA7E}" dt="2026-08-12T12:15:37.861" v="894" actId="2696"/>
-        <pc:sldMkLst>
-          <pc:docMk/>
-          <pc:sldMk cId="67448461" sldId="271"/>
-        </pc:sldMkLst>
-      </pc:sldChg>
-      <pc:sldChg chg="modSp del mod">
-        <pc:chgData name="Rich Reba" userId="55db41ab6eb3f845" providerId="LiveId" clId="{0E19DA16-244C-5B50-BE0F-52911DD4CA7E}" dt="2026-08-12T12:15:41.277" v="895" actId="2696"/>
-        <pc:sldMkLst>
-          <pc:docMk/>
-          <pc:sldMk cId="3088802820" sldId="272"/>
-        </pc:sldMkLst>
-        <pc:spChg chg="mod">
-          <ac:chgData name="Rich Reba" userId="55db41ab6eb3f845" providerId="LiveId" clId="{0E19DA16-244C-5B50-BE0F-52911DD4CA7E}" dt="2026-08-12T12:02:02.611" v="886" actId="20577"/>
-          <ac:spMkLst>
-            <pc:docMk/>
-            <pc:sldMk cId="3088802820" sldId="272"/>
-            <ac:spMk id="96" creationId="{00000000-0000-0000-0000-000000000000}"/>
-          </ac:spMkLst>
-        </pc:spChg>
-      </pc:sldChg>
-      <pc:sldChg chg="modSp">
-        <pc:chgData name="Rich Reba" userId="55db41ab6eb3f845" providerId="LiveId" clId="{0E19DA16-244C-5B50-BE0F-52911DD4CA7E}" dt="2026-08-09T19:39:54.762" v="885"/>
+      <pc:sldChg chg="delSp modSp mod">
+        <pc:chgData name="Rich Reba" userId="55db41ab6eb3f845" providerId="LiveId" clId="{0E19DA16-244C-5B50-BE0F-52911DD4CA7E}" dt="2026-08-14T16:48:20.935" v="929" actId="478"/>
         <pc:sldMkLst>
           <pc:docMk/>
           <pc:sldMk cId="2639682451" sldId="275"/>
         </pc:sldMkLst>
+        <pc:spChg chg="del">
+          <ac:chgData name="Rich Reba" userId="55db41ab6eb3f845" providerId="LiveId" clId="{0E19DA16-244C-5B50-BE0F-52911DD4CA7E}" dt="2026-08-14T16:48:20.935" v="929" actId="478"/>
+          <ac:spMkLst>
+            <pc:docMk/>
+            <pc:sldMk cId="2639682451" sldId="275"/>
+            <ac:spMk id="6" creationId="{7C30D5DC-2695-01BA-B05D-C3CC4747D7F4}"/>
+          </ac:spMkLst>
+        </pc:spChg>
         <pc:graphicFrameChg chg="mod">
           <ac:chgData name="Rich Reba" userId="55db41ab6eb3f845" providerId="LiveId" clId="{0E19DA16-244C-5B50-BE0F-52911DD4CA7E}" dt="2026-08-09T19:39:54.762" v="885"/>
           <ac:graphicFrameMkLst>
@@ -431,12 +403,43 @@
           </ac:graphicFrameMkLst>
         </pc:graphicFrameChg>
       </pc:sldChg>
-      <pc:sldChg chg="modSp mod">
-        <pc:chgData name="Rich Reba" userId="55db41ab6eb3f845" providerId="LiveId" clId="{0E19DA16-244C-5B50-BE0F-52911DD4CA7E}" dt="2026-08-09T19:16:36.022" v="255" actId="20577"/>
+      <pc:sldChg chg="delSp mod">
+        <pc:chgData name="Rich Reba" userId="55db41ab6eb3f845" providerId="LiveId" clId="{0E19DA16-244C-5B50-BE0F-52911DD4CA7E}" dt="2026-08-14T16:48:02.723" v="925" actId="478"/>
+        <pc:sldMkLst>
+          <pc:docMk/>
+          <pc:sldMk cId="3191730488" sldId="276"/>
+        </pc:sldMkLst>
+        <pc:spChg chg="del">
+          <ac:chgData name="Rich Reba" userId="55db41ab6eb3f845" providerId="LiveId" clId="{0E19DA16-244C-5B50-BE0F-52911DD4CA7E}" dt="2026-08-14T16:48:02.723" v="925" actId="478"/>
+          <ac:spMkLst>
+            <pc:docMk/>
+            <pc:sldMk cId="3191730488" sldId="276"/>
+            <ac:spMk id="2" creationId="{B53C39C2-BA45-92C3-D93B-96BF2FF7E2EA}"/>
+          </ac:spMkLst>
+        </pc:spChg>
+      </pc:sldChg>
+      <pc:sldChg chg="addSp delSp modSp mod">
+        <pc:chgData name="Rich Reba" userId="55db41ab6eb3f845" providerId="LiveId" clId="{0E19DA16-244C-5B50-BE0F-52911DD4CA7E}" dt="2026-08-14T16:48:34.631" v="930"/>
         <pc:sldMkLst>
           <pc:docMk/>
           <pc:sldMk cId="368434212" sldId="277"/>
         </pc:sldMkLst>
+        <pc:spChg chg="add mod">
+          <ac:chgData name="Rich Reba" userId="55db41ab6eb3f845" providerId="LiveId" clId="{0E19DA16-244C-5B50-BE0F-52911DD4CA7E}" dt="2026-08-14T16:48:34.631" v="930"/>
+          <ac:spMkLst>
+            <pc:docMk/>
+            <pc:sldMk cId="368434212" sldId="277"/>
+            <ac:spMk id="2" creationId="{DA37AE46-9A21-9F2C-0953-79B2B8C97D2B}"/>
+          </ac:spMkLst>
+        </pc:spChg>
+        <pc:spChg chg="del">
+          <ac:chgData name="Rich Reba" userId="55db41ab6eb3f845" providerId="LiveId" clId="{0E19DA16-244C-5B50-BE0F-52911DD4CA7E}" dt="2026-08-14T16:48:07.181" v="926" actId="478"/>
+          <ac:spMkLst>
+            <pc:docMk/>
+            <pc:sldMk cId="368434212" sldId="277"/>
+            <ac:spMk id="3" creationId="{7EF92490-8763-C122-9420-8771007CA2FA}"/>
+          </ac:spMkLst>
+        </pc:spChg>
         <pc:graphicFrameChg chg="modGraphic">
           <ac:chgData name="Rich Reba" userId="55db41ab6eb3f845" providerId="LiveId" clId="{0E19DA16-244C-5B50-BE0F-52911DD4CA7E}" dt="2026-08-09T19:16:36.022" v="255" actId="20577"/>
           <ac:graphicFrameMkLst>
@@ -445,6 +448,51 @@
             <ac:graphicFrameMk id="4" creationId="{DF0CCA37-1217-B7D3-8320-72D1D9B53C50}"/>
           </ac:graphicFrameMkLst>
         </pc:graphicFrameChg>
+      </pc:sldChg>
+      <pc:sldChg chg="delSp mod">
+        <pc:chgData name="Rich Reba" userId="55db41ab6eb3f845" providerId="LiveId" clId="{0E19DA16-244C-5B50-BE0F-52911DD4CA7E}" dt="2026-08-14T16:47:46.168" v="921" actId="478"/>
+        <pc:sldMkLst>
+          <pc:docMk/>
+          <pc:sldMk cId="3888112108" sldId="278"/>
+        </pc:sldMkLst>
+        <pc:spChg chg="del">
+          <ac:chgData name="Rich Reba" userId="55db41ab6eb3f845" providerId="LiveId" clId="{0E19DA16-244C-5B50-BE0F-52911DD4CA7E}" dt="2026-08-14T16:47:46.168" v="921" actId="478"/>
+          <ac:spMkLst>
+            <pc:docMk/>
+            <pc:sldMk cId="3888112108" sldId="278"/>
+            <ac:spMk id="2" creationId="{048B8078-0A98-B723-6D07-9C874B8373FA}"/>
+          </ac:spMkLst>
+        </pc:spChg>
+      </pc:sldChg>
+      <pc:sldChg chg="delSp mod">
+        <pc:chgData name="Rich Reba" userId="55db41ab6eb3f845" providerId="LiveId" clId="{0E19DA16-244C-5B50-BE0F-52911DD4CA7E}" dt="2026-08-14T16:47:58.137" v="924" actId="478"/>
+        <pc:sldMkLst>
+          <pc:docMk/>
+          <pc:sldMk cId="4099550087" sldId="279"/>
+        </pc:sldMkLst>
+        <pc:spChg chg="del">
+          <ac:chgData name="Rich Reba" userId="55db41ab6eb3f845" providerId="LiveId" clId="{0E19DA16-244C-5B50-BE0F-52911DD4CA7E}" dt="2026-08-14T16:47:58.137" v="924" actId="478"/>
+          <ac:spMkLst>
+            <pc:docMk/>
+            <pc:sldMk cId="4099550087" sldId="279"/>
+            <ac:spMk id="6" creationId="{7CAB671F-9BEE-E2C8-B532-9AAC16B0D9FC}"/>
+          </ac:spMkLst>
+        </pc:spChg>
+      </pc:sldChg>
+      <pc:sldChg chg="delSp mod">
+        <pc:chgData name="Rich Reba" userId="55db41ab6eb3f845" providerId="LiveId" clId="{0E19DA16-244C-5B50-BE0F-52911DD4CA7E}" dt="2026-08-14T16:48:17.836" v="928" actId="478"/>
+        <pc:sldMkLst>
+          <pc:docMk/>
+          <pc:sldMk cId="2970225831" sldId="280"/>
+        </pc:sldMkLst>
+        <pc:spChg chg="del">
+          <ac:chgData name="Rich Reba" userId="55db41ab6eb3f845" providerId="LiveId" clId="{0E19DA16-244C-5B50-BE0F-52911DD4CA7E}" dt="2026-08-14T16:48:17.836" v="928" actId="478"/>
+          <ac:spMkLst>
+            <pc:docMk/>
+            <pc:sldMk cId="2970225831" sldId="280"/>
+            <ac:spMk id="6" creationId="{ED514B9A-C821-414D-27E7-22058443F6B3}"/>
+          </ac:spMkLst>
+        </pc:spChg>
       </pc:sldChg>
       <pc:sldChg chg="modSp mod">
         <pc:chgData name="Rich Reba" userId="55db41ab6eb3f845" providerId="LiveId" clId="{0E19DA16-244C-5B50-BE0F-52911DD4CA7E}" dt="2026-08-09T19:39:31.854" v="883" actId="20577"/>
@@ -15604,151 +15652,8 @@
             </a:pPr>
             <a:r>
               <a:rPr lang="en-US" dirty="0"/>
-              <a:t>August 12, 2026</a:t>
+              <a:t>August 14, 2026</a:t>
             </a:r>
-          </a:p>
-        </p:txBody>
-      </p:sp>
-      <p:sp>
-        <p:nvSpPr>
-          <p:cNvPr id="2" name="Google Shape;18;p9">
-            <a:extLst>
-              <a:ext uri="{FF2B5EF4-FFF2-40B4-BE49-F238E27FC236}">
-                <a16:creationId xmlns:a16="http://schemas.microsoft.com/office/drawing/2014/main" id="{B78BEAA4-CC48-1EF1-1035-C48CDEB46C11}"/>
-              </a:ext>
-            </a:extLst>
-          </p:cNvPr>
-          <p:cNvSpPr txBox="1">
-            <a:spLocks noGrp="1"/>
-          </p:cNvSpPr>
-          <p:nvPr>
-            <p:ph type="ftr" idx="11"/>
-          </p:nvPr>
-        </p:nvSpPr>
-        <p:spPr>
-          <a:xfrm>
-            <a:off x="4038600" y="6356350"/>
-            <a:ext cx="4114800" cy="365125"/>
-          </a:xfrm>
-          <a:prstGeom prst="rect">
-            <a:avLst/>
-          </a:prstGeom>
-          <a:noFill/>
-          <a:ln>
-            <a:noFill/>
-          </a:ln>
-        </p:spPr>
-        <p:txBody>
-          <a:bodyPr spcFirstLastPara="1" wrap="square" lIns="91425" tIns="45700" rIns="91425" bIns="45700" anchor="ctr" anchorCtr="0">
-            <a:noAutofit/>
-          </a:bodyPr>
-          <a:lstStyle>
-            <a:lvl1pPr lvl="0" algn="ctr">
-              <a:spcBef>
-                <a:spcPts val="0"/>
-              </a:spcBef>
-              <a:spcAft>
-                <a:spcPts val="0"/>
-              </a:spcAft>
-              <a:buSzPts val="1400"/>
-              <a:buNone/>
-              <a:defRPr/>
-            </a:lvl1pPr>
-            <a:lvl2pPr lvl="1" algn="l">
-              <a:spcBef>
-                <a:spcPts val="0"/>
-              </a:spcBef>
-              <a:spcAft>
-                <a:spcPts val="0"/>
-              </a:spcAft>
-              <a:buSzPts val="1400"/>
-              <a:buNone/>
-              <a:defRPr/>
-            </a:lvl2pPr>
-            <a:lvl3pPr lvl="2" algn="l">
-              <a:spcBef>
-                <a:spcPts val="0"/>
-              </a:spcBef>
-              <a:spcAft>
-                <a:spcPts val="0"/>
-              </a:spcAft>
-              <a:buSzPts val="1400"/>
-              <a:buNone/>
-              <a:defRPr/>
-            </a:lvl3pPr>
-            <a:lvl4pPr lvl="3" algn="l">
-              <a:spcBef>
-                <a:spcPts val="0"/>
-              </a:spcBef>
-              <a:spcAft>
-                <a:spcPts val="0"/>
-              </a:spcAft>
-              <a:buSzPts val="1400"/>
-              <a:buNone/>
-              <a:defRPr/>
-            </a:lvl4pPr>
-            <a:lvl5pPr lvl="4" algn="l">
-              <a:spcBef>
-                <a:spcPts val="0"/>
-              </a:spcBef>
-              <a:spcAft>
-                <a:spcPts val="0"/>
-              </a:spcAft>
-              <a:buSzPts val="1400"/>
-              <a:buNone/>
-              <a:defRPr/>
-            </a:lvl5pPr>
-            <a:lvl6pPr lvl="5" algn="l">
-              <a:spcBef>
-                <a:spcPts val="0"/>
-              </a:spcBef>
-              <a:spcAft>
-                <a:spcPts val="0"/>
-              </a:spcAft>
-              <a:buSzPts val="1400"/>
-              <a:buNone/>
-              <a:defRPr/>
-            </a:lvl6pPr>
-            <a:lvl7pPr lvl="6" algn="l">
-              <a:spcBef>
-                <a:spcPts val="0"/>
-              </a:spcBef>
-              <a:spcAft>
-                <a:spcPts val="0"/>
-              </a:spcAft>
-              <a:buSzPts val="1400"/>
-              <a:buNone/>
-              <a:defRPr/>
-            </a:lvl7pPr>
-            <a:lvl8pPr lvl="7" algn="l">
-              <a:spcBef>
-                <a:spcPts val="0"/>
-              </a:spcBef>
-              <a:spcAft>
-                <a:spcPts val="0"/>
-              </a:spcAft>
-              <a:buSzPts val="1400"/>
-              <a:buNone/>
-              <a:defRPr/>
-            </a:lvl8pPr>
-            <a:lvl9pPr lvl="8" algn="l">
-              <a:spcBef>
-                <a:spcPts val="0"/>
-              </a:spcBef>
-              <a:spcAft>
-                <a:spcPts val="0"/>
-              </a:spcAft>
-              <a:buSzPts val="1400"/>
-              <a:buNone/>
-              <a:defRPr/>
-            </a:lvl9pPr>
-          </a:lstStyle>
-          <a:p>
-            <a:r>
-              <a:rPr lang="en-US" dirty="0"/>
-              <a:t>Proprietary and Confidential Information</a:t>
-            </a:r>
-            <a:endParaRPr dirty="0"/>
           </a:p>
         </p:txBody>
       </p:sp>
@@ -16064,149 +15969,6 @@
           </a:p>
         </p:txBody>
       </p:sp>
-      <p:sp>
-        <p:nvSpPr>
-          <p:cNvPr id="6" name="Google Shape;18;p9">
-            <a:extLst>
-              <a:ext uri="{FF2B5EF4-FFF2-40B4-BE49-F238E27FC236}">
-                <a16:creationId xmlns:a16="http://schemas.microsoft.com/office/drawing/2014/main" id="{ED514B9A-C821-414D-27E7-22058443F6B3}"/>
-              </a:ext>
-            </a:extLst>
-          </p:cNvPr>
-          <p:cNvSpPr txBox="1">
-            <a:spLocks noGrp="1"/>
-          </p:cNvSpPr>
-          <p:nvPr>
-            <p:ph type="ftr" idx="11"/>
-          </p:nvPr>
-        </p:nvSpPr>
-        <p:spPr>
-          <a:xfrm>
-            <a:off x="4038600" y="6356350"/>
-            <a:ext cx="4114800" cy="365125"/>
-          </a:xfrm>
-          <a:prstGeom prst="rect">
-            <a:avLst/>
-          </a:prstGeom>
-          <a:noFill/>
-          <a:ln>
-            <a:noFill/>
-          </a:ln>
-        </p:spPr>
-        <p:txBody>
-          <a:bodyPr spcFirstLastPara="1" wrap="square" lIns="91425" tIns="45700" rIns="91425" bIns="45700" anchor="ctr" anchorCtr="0">
-            <a:noAutofit/>
-          </a:bodyPr>
-          <a:lstStyle>
-            <a:lvl1pPr lvl="0" algn="ctr">
-              <a:spcBef>
-                <a:spcPts val="0"/>
-              </a:spcBef>
-              <a:spcAft>
-                <a:spcPts val="0"/>
-              </a:spcAft>
-              <a:buSzPts val="1400"/>
-              <a:buNone/>
-              <a:defRPr/>
-            </a:lvl1pPr>
-            <a:lvl2pPr lvl="1" algn="l">
-              <a:spcBef>
-                <a:spcPts val="0"/>
-              </a:spcBef>
-              <a:spcAft>
-                <a:spcPts val="0"/>
-              </a:spcAft>
-              <a:buSzPts val="1400"/>
-              <a:buNone/>
-              <a:defRPr/>
-            </a:lvl2pPr>
-            <a:lvl3pPr lvl="2" algn="l">
-              <a:spcBef>
-                <a:spcPts val="0"/>
-              </a:spcBef>
-              <a:spcAft>
-                <a:spcPts val="0"/>
-              </a:spcAft>
-              <a:buSzPts val="1400"/>
-              <a:buNone/>
-              <a:defRPr/>
-            </a:lvl3pPr>
-            <a:lvl4pPr lvl="3" algn="l">
-              <a:spcBef>
-                <a:spcPts val="0"/>
-              </a:spcBef>
-              <a:spcAft>
-                <a:spcPts val="0"/>
-              </a:spcAft>
-              <a:buSzPts val="1400"/>
-              <a:buNone/>
-              <a:defRPr/>
-            </a:lvl4pPr>
-            <a:lvl5pPr lvl="4" algn="l">
-              <a:spcBef>
-                <a:spcPts val="0"/>
-              </a:spcBef>
-              <a:spcAft>
-                <a:spcPts val="0"/>
-              </a:spcAft>
-              <a:buSzPts val="1400"/>
-              <a:buNone/>
-              <a:defRPr/>
-            </a:lvl5pPr>
-            <a:lvl6pPr lvl="5" algn="l">
-              <a:spcBef>
-                <a:spcPts val="0"/>
-              </a:spcBef>
-              <a:spcAft>
-                <a:spcPts val="0"/>
-              </a:spcAft>
-              <a:buSzPts val="1400"/>
-              <a:buNone/>
-              <a:defRPr/>
-            </a:lvl6pPr>
-            <a:lvl7pPr lvl="6" algn="l">
-              <a:spcBef>
-                <a:spcPts val="0"/>
-              </a:spcBef>
-              <a:spcAft>
-                <a:spcPts val="0"/>
-              </a:spcAft>
-              <a:buSzPts val="1400"/>
-              <a:buNone/>
-              <a:defRPr/>
-            </a:lvl7pPr>
-            <a:lvl8pPr lvl="7" algn="l">
-              <a:spcBef>
-                <a:spcPts val="0"/>
-              </a:spcBef>
-              <a:spcAft>
-                <a:spcPts val="0"/>
-              </a:spcAft>
-              <a:buSzPts val="1400"/>
-              <a:buNone/>
-              <a:defRPr/>
-            </a:lvl8pPr>
-            <a:lvl9pPr lvl="8" algn="l">
-              <a:spcBef>
-                <a:spcPts val="0"/>
-              </a:spcBef>
-              <a:spcAft>
-                <a:spcPts val="0"/>
-              </a:spcAft>
-              <a:buSzPts val="1400"/>
-              <a:buNone/>
-              <a:defRPr/>
-            </a:lvl9pPr>
-          </a:lstStyle>
-          <a:p>
-            <a:r>
-              <a:rPr lang="en-US" dirty="0"/>
-              <a:t>Proprietary and Confidential Information</a:t>
-            </a:r>
-            <a:endParaRPr dirty="0"/>
-          </a:p>
-        </p:txBody>
-      </p:sp>
     </p:spTree>
     <p:extLst>
       <p:ext uri="{BB962C8B-B14F-4D97-AF65-F5344CB8AC3E}">
@@ -16543,149 +16305,6 @@
               </a:rPr>
               <a:t>Implementing - MVP Stage</a:t>
             </a:r>
-          </a:p>
-        </p:txBody>
-      </p:sp>
-      <p:sp>
-        <p:nvSpPr>
-          <p:cNvPr id="6" name="Google Shape;18;p9">
-            <a:extLst>
-              <a:ext uri="{FF2B5EF4-FFF2-40B4-BE49-F238E27FC236}">
-                <a16:creationId xmlns:a16="http://schemas.microsoft.com/office/drawing/2014/main" id="{7C30D5DC-2695-01BA-B05D-C3CC4747D7F4}"/>
-              </a:ext>
-            </a:extLst>
-          </p:cNvPr>
-          <p:cNvSpPr txBox="1">
-            <a:spLocks noGrp="1"/>
-          </p:cNvSpPr>
-          <p:nvPr>
-            <p:ph type="ftr" idx="11"/>
-          </p:nvPr>
-        </p:nvSpPr>
-        <p:spPr>
-          <a:xfrm>
-            <a:off x="4038600" y="6356350"/>
-            <a:ext cx="4114800" cy="365125"/>
-          </a:xfrm>
-          <a:prstGeom prst="rect">
-            <a:avLst/>
-          </a:prstGeom>
-          <a:noFill/>
-          <a:ln>
-            <a:noFill/>
-          </a:ln>
-        </p:spPr>
-        <p:txBody>
-          <a:bodyPr spcFirstLastPara="1" wrap="square" lIns="91425" tIns="45700" rIns="91425" bIns="45700" anchor="ctr" anchorCtr="0">
-            <a:noAutofit/>
-          </a:bodyPr>
-          <a:lstStyle>
-            <a:lvl1pPr lvl="0" algn="ctr">
-              <a:spcBef>
-                <a:spcPts val="0"/>
-              </a:spcBef>
-              <a:spcAft>
-                <a:spcPts val="0"/>
-              </a:spcAft>
-              <a:buSzPts val="1400"/>
-              <a:buNone/>
-              <a:defRPr/>
-            </a:lvl1pPr>
-            <a:lvl2pPr lvl="1" algn="l">
-              <a:spcBef>
-                <a:spcPts val="0"/>
-              </a:spcBef>
-              <a:spcAft>
-                <a:spcPts val="0"/>
-              </a:spcAft>
-              <a:buSzPts val="1400"/>
-              <a:buNone/>
-              <a:defRPr/>
-            </a:lvl2pPr>
-            <a:lvl3pPr lvl="2" algn="l">
-              <a:spcBef>
-                <a:spcPts val="0"/>
-              </a:spcBef>
-              <a:spcAft>
-                <a:spcPts val="0"/>
-              </a:spcAft>
-              <a:buSzPts val="1400"/>
-              <a:buNone/>
-              <a:defRPr/>
-            </a:lvl3pPr>
-            <a:lvl4pPr lvl="3" algn="l">
-              <a:spcBef>
-                <a:spcPts val="0"/>
-              </a:spcBef>
-              <a:spcAft>
-                <a:spcPts val="0"/>
-              </a:spcAft>
-              <a:buSzPts val="1400"/>
-              <a:buNone/>
-              <a:defRPr/>
-            </a:lvl4pPr>
-            <a:lvl5pPr lvl="4" algn="l">
-              <a:spcBef>
-                <a:spcPts val="0"/>
-              </a:spcBef>
-              <a:spcAft>
-                <a:spcPts val="0"/>
-              </a:spcAft>
-              <a:buSzPts val="1400"/>
-              <a:buNone/>
-              <a:defRPr/>
-            </a:lvl5pPr>
-            <a:lvl6pPr lvl="5" algn="l">
-              <a:spcBef>
-                <a:spcPts val="0"/>
-              </a:spcBef>
-              <a:spcAft>
-                <a:spcPts val="0"/>
-              </a:spcAft>
-              <a:buSzPts val="1400"/>
-              <a:buNone/>
-              <a:defRPr/>
-            </a:lvl6pPr>
-            <a:lvl7pPr lvl="6" algn="l">
-              <a:spcBef>
-                <a:spcPts val="0"/>
-              </a:spcBef>
-              <a:spcAft>
-                <a:spcPts val="0"/>
-              </a:spcAft>
-              <a:buSzPts val="1400"/>
-              <a:buNone/>
-              <a:defRPr/>
-            </a:lvl7pPr>
-            <a:lvl8pPr lvl="7" algn="l">
-              <a:spcBef>
-                <a:spcPts val="0"/>
-              </a:spcBef>
-              <a:spcAft>
-                <a:spcPts val="0"/>
-              </a:spcAft>
-              <a:buSzPts val="1400"/>
-              <a:buNone/>
-              <a:defRPr/>
-            </a:lvl8pPr>
-            <a:lvl9pPr lvl="8" algn="l">
-              <a:spcBef>
-                <a:spcPts val="0"/>
-              </a:spcBef>
-              <a:spcAft>
-                <a:spcPts val="0"/>
-              </a:spcAft>
-              <a:buSzPts val="1400"/>
-              <a:buNone/>
-              <a:defRPr/>
-            </a:lvl9pPr>
-          </a:lstStyle>
-          <a:p>
-            <a:r>
-              <a:rPr lang="en-US" dirty="0"/>
-              <a:t>Proprietary and Confidential Information</a:t>
-            </a:r>
-            <a:endParaRPr dirty="0"/>
           </a:p>
         </p:txBody>
       </p:sp>
@@ -17358,149 +16977,6 @@
           </a:p>
         </p:txBody>
       </p:sp>
-      <p:sp>
-        <p:nvSpPr>
-          <p:cNvPr id="2" name="Google Shape;18;p9">
-            <a:extLst>
-              <a:ext uri="{FF2B5EF4-FFF2-40B4-BE49-F238E27FC236}">
-                <a16:creationId xmlns:a16="http://schemas.microsoft.com/office/drawing/2014/main" id="{048B8078-0A98-B723-6D07-9C874B8373FA}"/>
-              </a:ext>
-            </a:extLst>
-          </p:cNvPr>
-          <p:cNvSpPr txBox="1">
-            <a:spLocks noGrp="1"/>
-          </p:cNvSpPr>
-          <p:nvPr>
-            <p:ph type="ftr" idx="11"/>
-          </p:nvPr>
-        </p:nvSpPr>
-        <p:spPr>
-          <a:xfrm>
-            <a:off x="4038600" y="6356350"/>
-            <a:ext cx="4114800" cy="365125"/>
-          </a:xfrm>
-          <a:prstGeom prst="rect">
-            <a:avLst/>
-          </a:prstGeom>
-          <a:noFill/>
-          <a:ln>
-            <a:noFill/>
-          </a:ln>
-        </p:spPr>
-        <p:txBody>
-          <a:bodyPr spcFirstLastPara="1" wrap="square" lIns="91425" tIns="45700" rIns="91425" bIns="45700" anchor="ctr" anchorCtr="0">
-            <a:noAutofit/>
-          </a:bodyPr>
-          <a:lstStyle>
-            <a:lvl1pPr lvl="0" algn="ctr">
-              <a:spcBef>
-                <a:spcPts val="0"/>
-              </a:spcBef>
-              <a:spcAft>
-                <a:spcPts val="0"/>
-              </a:spcAft>
-              <a:buSzPts val="1400"/>
-              <a:buNone/>
-              <a:defRPr/>
-            </a:lvl1pPr>
-            <a:lvl2pPr lvl="1" algn="l">
-              <a:spcBef>
-                <a:spcPts val="0"/>
-              </a:spcBef>
-              <a:spcAft>
-                <a:spcPts val="0"/>
-              </a:spcAft>
-              <a:buSzPts val="1400"/>
-              <a:buNone/>
-              <a:defRPr/>
-            </a:lvl2pPr>
-            <a:lvl3pPr lvl="2" algn="l">
-              <a:spcBef>
-                <a:spcPts val="0"/>
-              </a:spcBef>
-              <a:spcAft>
-                <a:spcPts val="0"/>
-              </a:spcAft>
-              <a:buSzPts val="1400"/>
-              <a:buNone/>
-              <a:defRPr/>
-            </a:lvl3pPr>
-            <a:lvl4pPr lvl="3" algn="l">
-              <a:spcBef>
-                <a:spcPts val="0"/>
-              </a:spcBef>
-              <a:spcAft>
-                <a:spcPts val="0"/>
-              </a:spcAft>
-              <a:buSzPts val="1400"/>
-              <a:buNone/>
-              <a:defRPr/>
-            </a:lvl4pPr>
-            <a:lvl5pPr lvl="4" algn="l">
-              <a:spcBef>
-                <a:spcPts val="0"/>
-              </a:spcBef>
-              <a:spcAft>
-                <a:spcPts val="0"/>
-              </a:spcAft>
-              <a:buSzPts val="1400"/>
-              <a:buNone/>
-              <a:defRPr/>
-            </a:lvl5pPr>
-            <a:lvl6pPr lvl="5" algn="l">
-              <a:spcBef>
-                <a:spcPts val="0"/>
-              </a:spcBef>
-              <a:spcAft>
-                <a:spcPts val="0"/>
-              </a:spcAft>
-              <a:buSzPts val="1400"/>
-              <a:buNone/>
-              <a:defRPr/>
-            </a:lvl6pPr>
-            <a:lvl7pPr lvl="6" algn="l">
-              <a:spcBef>
-                <a:spcPts val="0"/>
-              </a:spcBef>
-              <a:spcAft>
-                <a:spcPts val="0"/>
-              </a:spcAft>
-              <a:buSzPts val="1400"/>
-              <a:buNone/>
-              <a:defRPr/>
-            </a:lvl7pPr>
-            <a:lvl8pPr lvl="7" algn="l">
-              <a:spcBef>
-                <a:spcPts val="0"/>
-              </a:spcBef>
-              <a:spcAft>
-                <a:spcPts val="0"/>
-              </a:spcAft>
-              <a:buSzPts val="1400"/>
-              <a:buNone/>
-              <a:defRPr/>
-            </a:lvl8pPr>
-            <a:lvl9pPr lvl="8" algn="l">
-              <a:spcBef>
-                <a:spcPts val="0"/>
-              </a:spcBef>
-              <a:spcAft>
-                <a:spcPts val="0"/>
-              </a:spcAft>
-              <a:buSzPts val="1400"/>
-              <a:buNone/>
-              <a:defRPr/>
-            </a:lvl9pPr>
-          </a:lstStyle>
-          <a:p>
-            <a:r>
-              <a:rPr lang="en-US" dirty="0"/>
-              <a:t>Proprietary and Confidential Information</a:t>
-            </a:r>
-            <a:endParaRPr dirty="0"/>
-          </a:p>
-        </p:txBody>
-      </p:sp>
     </p:spTree>
     <p:extLst>
       <p:ext uri="{BB962C8B-B14F-4D97-AF65-F5344CB8AC3E}">
@@ -17830,149 +17306,6 @@
               </a:rPr>
               <a:t>Implementing - MVP Stage</a:t>
             </a:r>
-          </a:p>
-        </p:txBody>
-      </p:sp>
-      <p:sp>
-        <p:nvSpPr>
-          <p:cNvPr id="6" name="Google Shape;18;p9">
-            <a:extLst>
-              <a:ext uri="{FF2B5EF4-FFF2-40B4-BE49-F238E27FC236}">
-                <a16:creationId xmlns:a16="http://schemas.microsoft.com/office/drawing/2014/main" id="{F57F7845-FD8A-DCA4-39DB-1B7D9CF0BA2A}"/>
-              </a:ext>
-            </a:extLst>
-          </p:cNvPr>
-          <p:cNvSpPr txBox="1">
-            <a:spLocks noGrp="1"/>
-          </p:cNvSpPr>
-          <p:nvPr>
-            <p:ph type="ftr" idx="11"/>
-          </p:nvPr>
-        </p:nvSpPr>
-        <p:spPr>
-          <a:xfrm>
-            <a:off x="4038600" y="6556766"/>
-            <a:ext cx="4114800" cy="365125"/>
-          </a:xfrm>
-          <a:prstGeom prst="rect">
-            <a:avLst/>
-          </a:prstGeom>
-          <a:noFill/>
-          <a:ln>
-            <a:noFill/>
-          </a:ln>
-        </p:spPr>
-        <p:txBody>
-          <a:bodyPr spcFirstLastPara="1" wrap="square" lIns="91425" tIns="45700" rIns="91425" bIns="45700" anchor="ctr" anchorCtr="0">
-            <a:noAutofit/>
-          </a:bodyPr>
-          <a:lstStyle>
-            <a:lvl1pPr lvl="0" algn="ctr">
-              <a:spcBef>
-                <a:spcPts val="0"/>
-              </a:spcBef>
-              <a:spcAft>
-                <a:spcPts val="0"/>
-              </a:spcAft>
-              <a:buSzPts val="1400"/>
-              <a:buNone/>
-              <a:defRPr/>
-            </a:lvl1pPr>
-            <a:lvl2pPr lvl="1" algn="l">
-              <a:spcBef>
-                <a:spcPts val="0"/>
-              </a:spcBef>
-              <a:spcAft>
-                <a:spcPts val="0"/>
-              </a:spcAft>
-              <a:buSzPts val="1400"/>
-              <a:buNone/>
-              <a:defRPr/>
-            </a:lvl2pPr>
-            <a:lvl3pPr lvl="2" algn="l">
-              <a:spcBef>
-                <a:spcPts val="0"/>
-              </a:spcBef>
-              <a:spcAft>
-                <a:spcPts val="0"/>
-              </a:spcAft>
-              <a:buSzPts val="1400"/>
-              <a:buNone/>
-              <a:defRPr/>
-            </a:lvl3pPr>
-            <a:lvl4pPr lvl="3" algn="l">
-              <a:spcBef>
-                <a:spcPts val="0"/>
-              </a:spcBef>
-              <a:spcAft>
-                <a:spcPts val="0"/>
-              </a:spcAft>
-              <a:buSzPts val="1400"/>
-              <a:buNone/>
-              <a:defRPr/>
-            </a:lvl4pPr>
-            <a:lvl5pPr lvl="4" algn="l">
-              <a:spcBef>
-                <a:spcPts val="0"/>
-              </a:spcBef>
-              <a:spcAft>
-                <a:spcPts val="0"/>
-              </a:spcAft>
-              <a:buSzPts val="1400"/>
-              <a:buNone/>
-              <a:defRPr/>
-            </a:lvl5pPr>
-            <a:lvl6pPr lvl="5" algn="l">
-              <a:spcBef>
-                <a:spcPts val="0"/>
-              </a:spcBef>
-              <a:spcAft>
-                <a:spcPts val="0"/>
-              </a:spcAft>
-              <a:buSzPts val="1400"/>
-              <a:buNone/>
-              <a:defRPr/>
-            </a:lvl6pPr>
-            <a:lvl7pPr lvl="6" algn="l">
-              <a:spcBef>
-                <a:spcPts val="0"/>
-              </a:spcBef>
-              <a:spcAft>
-                <a:spcPts val="0"/>
-              </a:spcAft>
-              <a:buSzPts val="1400"/>
-              <a:buNone/>
-              <a:defRPr/>
-            </a:lvl7pPr>
-            <a:lvl8pPr lvl="7" algn="l">
-              <a:spcBef>
-                <a:spcPts val="0"/>
-              </a:spcBef>
-              <a:spcAft>
-                <a:spcPts val="0"/>
-              </a:spcAft>
-              <a:buSzPts val="1400"/>
-              <a:buNone/>
-              <a:defRPr/>
-            </a:lvl8pPr>
-            <a:lvl9pPr lvl="8" algn="l">
-              <a:spcBef>
-                <a:spcPts val="0"/>
-              </a:spcBef>
-              <a:spcAft>
-                <a:spcPts val="0"/>
-              </a:spcAft>
-              <a:buSzPts val="1400"/>
-              <a:buNone/>
-              <a:defRPr/>
-            </a:lvl9pPr>
-          </a:lstStyle>
-          <a:p>
-            <a:r>
-              <a:rPr lang="en-US" dirty="0"/>
-              <a:t>Proprietary and Confidential Information</a:t>
-            </a:r>
-            <a:endParaRPr dirty="0"/>
           </a:p>
         </p:txBody>
       </p:sp>
@@ -18960,149 +18293,6 @@
       </p:graphicFrame>
       <p:sp>
         <p:nvSpPr>
-          <p:cNvPr id="5" name="Google Shape;18;p9">
-            <a:extLst>
-              <a:ext uri="{FF2B5EF4-FFF2-40B4-BE49-F238E27FC236}">
-                <a16:creationId xmlns:a16="http://schemas.microsoft.com/office/drawing/2014/main" id="{C5748C3E-8A70-958C-B8E4-332FC5861BB3}"/>
-              </a:ext>
-            </a:extLst>
-          </p:cNvPr>
-          <p:cNvSpPr txBox="1">
-            <a:spLocks noGrp="1"/>
-          </p:cNvSpPr>
-          <p:nvPr>
-            <p:ph type="ftr" idx="11"/>
-          </p:nvPr>
-        </p:nvSpPr>
-        <p:spPr>
-          <a:xfrm>
-            <a:off x="4038600" y="6545917"/>
-            <a:ext cx="4114800" cy="365125"/>
-          </a:xfrm>
-          <a:prstGeom prst="rect">
-            <a:avLst/>
-          </a:prstGeom>
-          <a:noFill/>
-          <a:ln>
-            <a:noFill/>
-          </a:ln>
-        </p:spPr>
-        <p:txBody>
-          <a:bodyPr spcFirstLastPara="1" wrap="square" lIns="91425" tIns="45700" rIns="91425" bIns="45700" anchor="ctr" anchorCtr="0">
-            <a:noAutofit/>
-          </a:bodyPr>
-          <a:lstStyle>
-            <a:lvl1pPr lvl="0" algn="ctr">
-              <a:spcBef>
-                <a:spcPts val="0"/>
-              </a:spcBef>
-              <a:spcAft>
-                <a:spcPts val="0"/>
-              </a:spcAft>
-              <a:buSzPts val="1400"/>
-              <a:buNone/>
-              <a:defRPr/>
-            </a:lvl1pPr>
-            <a:lvl2pPr lvl="1" algn="l">
-              <a:spcBef>
-                <a:spcPts val="0"/>
-              </a:spcBef>
-              <a:spcAft>
-                <a:spcPts val="0"/>
-              </a:spcAft>
-              <a:buSzPts val="1400"/>
-              <a:buNone/>
-              <a:defRPr/>
-            </a:lvl2pPr>
-            <a:lvl3pPr lvl="2" algn="l">
-              <a:spcBef>
-                <a:spcPts val="0"/>
-              </a:spcBef>
-              <a:spcAft>
-                <a:spcPts val="0"/>
-              </a:spcAft>
-              <a:buSzPts val="1400"/>
-              <a:buNone/>
-              <a:defRPr/>
-            </a:lvl3pPr>
-            <a:lvl4pPr lvl="3" algn="l">
-              <a:spcBef>
-                <a:spcPts val="0"/>
-              </a:spcBef>
-              <a:spcAft>
-                <a:spcPts val="0"/>
-              </a:spcAft>
-              <a:buSzPts val="1400"/>
-              <a:buNone/>
-              <a:defRPr/>
-            </a:lvl4pPr>
-            <a:lvl5pPr lvl="4" algn="l">
-              <a:spcBef>
-                <a:spcPts val="0"/>
-              </a:spcBef>
-              <a:spcAft>
-                <a:spcPts val="0"/>
-              </a:spcAft>
-              <a:buSzPts val="1400"/>
-              <a:buNone/>
-              <a:defRPr/>
-            </a:lvl5pPr>
-            <a:lvl6pPr lvl="5" algn="l">
-              <a:spcBef>
-                <a:spcPts val="0"/>
-              </a:spcBef>
-              <a:spcAft>
-                <a:spcPts val="0"/>
-              </a:spcAft>
-              <a:buSzPts val="1400"/>
-              <a:buNone/>
-              <a:defRPr/>
-            </a:lvl6pPr>
-            <a:lvl7pPr lvl="6" algn="l">
-              <a:spcBef>
-                <a:spcPts val="0"/>
-              </a:spcBef>
-              <a:spcAft>
-                <a:spcPts val="0"/>
-              </a:spcAft>
-              <a:buSzPts val="1400"/>
-              <a:buNone/>
-              <a:defRPr/>
-            </a:lvl7pPr>
-            <a:lvl8pPr lvl="7" algn="l">
-              <a:spcBef>
-                <a:spcPts val="0"/>
-              </a:spcBef>
-              <a:spcAft>
-                <a:spcPts val="0"/>
-              </a:spcAft>
-              <a:buSzPts val="1400"/>
-              <a:buNone/>
-              <a:defRPr/>
-            </a:lvl8pPr>
-            <a:lvl9pPr lvl="8" algn="l">
-              <a:spcBef>
-                <a:spcPts val="0"/>
-              </a:spcBef>
-              <a:spcAft>
-                <a:spcPts val="0"/>
-              </a:spcAft>
-              <a:buSzPts val="1400"/>
-              <a:buNone/>
-              <a:defRPr/>
-            </a:lvl9pPr>
-          </a:lstStyle>
-          <a:p>
-            <a:r>
-              <a:rPr lang="en-US" dirty="0"/>
-              <a:t>Proprietary and Confidential Information</a:t>
-            </a:r>
-            <a:endParaRPr dirty="0"/>
-          </a:p>
-        </p:txBody>
-      </p:sp>
-      <p:sp>
-        <p:nvSpPr>
           <p:cNvPr id="7" name="TextBox 6">
             <a:extLst>
               <a:ext uri="{FF2B5EF4-FFF2-40B4-BE49-F238E27FC236}">
@@ -19460,149 +18650,6 @@
               </a:rPr>
               <a:t>Implementing - MVP Stage</a:t>
             </a:r>
-          </a:p>
-        </p:txBody>
-      </p:sp>
-      <p:sp>
-        <p:nvSpPr>
-          <p:cNvPr id="6" name="Google Shape;18;p9">
-            <a:extLst>
-              <a:ext uri="{FF2B5EF4-FFF2-40B4-BE49-F238E27FC236}">
-                <a16:creationId xmlns:a16="http://schemas.microsoft.com/office/drawing/2014/main" id="{7CAB671F-9BEE-E2C8-B532-9AAC16B0D9FC}"/>
-              </a:ext>
-            </a:extLst>
-          </p:cNvPr>
-          <p:cNvSpPr txBox="1">
-            <a:spLocks noGrp="1"/>
-          </p:cNvSpPr>
-          <p:nvPr>
-            <p:ph type="ftr" idx="11"/>
-          </p:nvPr>
-        </p:nvSpPr>
-        <p:spPr>
-          <a:xfrm>
-            <a:off x="4038600" y="6356350"/>
-            <a:ext cx="4114800" cy="365125"/>
-          </a:xfrm>
-          <a:prstGeom prst="rect">
-            <a:avLst/>
-          </a:prstGeom>
-          <a:noFill/>
-          <a:ln>
-            <a:noFill/>
-          </a:ln>
-        </p:spPr>
-        <p:txBody>
-          <a:bodyPr spcFirstLastPara="1" wrap="square" lIns="91425" tIns="45700" rIns="91425" bIns="45700" anchor="ctr" anchorCtr="0">
-            <a:noAutofit/>
-          </a:bodyPr>
-          <a:lstStyle>
-            <a:lvl1pPr lvl="0" algn="ctr">
-              <a:spcBef>
-                <a:spcPts val="0"/>
-              </a:spcBef>
-              <a:spcAft>
-                <a:spcPts val="0"/>
-              </a:spcAft>
-              <a:buSzPts val="1400"/>
-              <a:buNone/>
-              <a:defRPr/>
-            </a:lvl1pPr>
-            <a:lvl2pPr lvl="1" algn="l">
-              <a:spcBef>
-                <a:spcPts val="0"/>
-              </a:spcBef>
-              <a:spcAft>
-                <a:spcPts val="0"/>
-              </a:spcAft>
-              <a:buSzPts val="1400"/>
-              <a:buNone/>
-              <a:defRPr/>
-            </a:lvl2pPr>
-            <a:lvl3pPr lvl="2" algn="l">
-              <a:spcBef>
-                <a:spcPts val="0"/>
-              </a:spcBef>
-              <a:spcAft>
-                <a:spcPts val="0"/>
-              </a:spcAft>
-              <a:buSzPts val="1400"/>
-              <a:buNone/>
-              <a:defRPr/>
-            </a:lvl3pPr>
-            <a:lvl4pPr lvl="3" algn="l">
-              <a:spcBef>
-                <a:spcPts val="0"/>
-              </a:spcBef>
-              <a:spcAft>
-                <a:spcPts val="0"/>
-              </a:spcAft>
-              <a:buSzPts val="1400"/>
-              <a:buNone/>
-              <a:defRPr/>
-            </a:lvl4pPr>
-            <a:lvl5pPr lvl="4" algn="l">
-              <a:spcBef>
-                <a:spcPts val="0"/>
-              </a:spcBef>
-              <a:spcAft>
-                <a:spcPts val="0"/>
-              </a:spcAft>
-              <a:buSzPts val="1400"/>
-              <a:buNone/>
-              <a:defRPr/>
-            </a:lvl5pPr>
-            <a:lvl6pPr lvl="5" algn="l">
-              <a:spcBef>
-                <a:spcPts val="0"/>
-              </a:spcBef>
-              <a:spcAft>
-                <a:spcPts val="0"/>
-              </a:spcAft>
-              <a:buSzPts val="1400"/>
-              <a:buNone/>
-              <a:defRPr/>
-            </a:lvl6pPr>
-            <a:lvl7pPr lvl="6" algn="l">
-              <a:spcBef>
-                <a:spcPts val="0"/>
-              </a:spcBef>
-              <a:spcAft>
-                <a:spcPts val="0"/>
-              </a:spcAft>
-              <a:buSzPts val="1400"/>
-              <a:buNone/>
-              <a:defRPr/>
-            </a:lvl7pPr>
-            <a:lvl8pPr lvl="7" algn="l">
-              <a:spcBef>
-                <a:spcPts val="0"/>
-              </a:spcBef>
-              <a:spcAft>
-                <a:spcPts val="0"/>
-              </a:spcAft>
-              <a:buSzPts val="1400"/>
-              <a:buNone/>
-              <a:defRPr/>
-            </a:lvl8pPr>
-            <a:lvl9pPr lvl="8" algn="l">
-              <a:spcBef>
-                <a:spcPts val="0"/>
-              </a:spcBef>
-              <a:spcAft>
-                <a:spcPts val="0"/>
-              </a:spcAft>
-              <a:buSzPts val="1400"/>
-              <a:buNone/>
-              <a:defRPr/>
-            </a:lvl9pPr>
-          </a:lstStyle>
-          <a:p>
-            <a:r>
-              <a:rPr lang="en-US" dirty="0"/>
-              <a:t>Proprietary and Confidential Information</a:t>
-            </a:r>
-            <a:endParaRPr dirty="0"/>
           </a:p>
         </p:txBody>
       </p:sp>
@@ -20106,149 +19153,6 @@
           </a:p>
         </p:txBody>
       </p:sp>
-      <p:sp>
-        <p:nvSpPr>
-          <p:cNvPr id="2" name="Google Shape;18;p9">
-            <a:extLst>
-              <a:ext uri="{FF2B5EF4-FFF2-40B4-BE49-F238E27FC236}">
-                <a16:creationId xmlns:a16="http://schemas.microsoft.com/office/drawing/2014/main" id="{B53C39C2-BA45-92C3-D93B-96BF2FF7E2EA}"/>
-              </a:ext>
-            </a:extLst>
-          </p:cNvPr>
-          <p:cNvSpPr txBox="1">
-            <a:spLocks noGrp="1"/>
-          </p:cNvSpPr>
-          <p:nvPr>
-            <p:ph type="ftr" idx="11"/>
-          </p:nvPr>
-        </p:nvSpPr>
-        <p:spPr>
-          <a:xfrm>
-            <a:off x="4038600" y="6356350"/>
-            <a:ext cx="4114800" cy="365125"/>
-          </a:xfrm>
-          <a:prstGeom prst="rect">
-            <a:avLst/>
-          </a:prstGeom>
-          <a:noFill/>
-          <a:ln>
-            <a:noFill/>
-          </a:ln>
-        </p:spPr>
-        <p:txBody>
-          <a:bodyPr spcFirstLastPara="1" wrap="square" lIns="91425" tIns="45700" rIns="91425" bIns="45700" anchor="ctr" anchorCtr="0">
-            <a:noAutofit/>
-          </a:bodyPr>
-          <a:lstStyle>
-            <a:lvl1pPr lvl="0" algn="ctr">
-              <a:spcBef>
-                <a:spcPts val="0"/>
-              </a:spcBef>
-              <a:spcAft>
-                <a:spcPts val="0"/>
-              </a:spcAft>
-              <a:buSzPts val="1400"/>
-              <a:buNone/>
-              <a:defRPr/>
-            </a:lvl1pPr>
-            <a:lvl2pPr lvl="1" algn="l">
-              <a:spcBef>
-                <a:spcPts val="0"/>
-              </a:spcBef>
-              <a:spcAft>
-                <a:spcPts val="0"/>
-              </a:spcAft>
-              <a:buSzPts val="1400"/>
-              <a:buNone/>
-              <a:defRPr/>
-            </a:lvl2pPr>
-            <a:lvl3pPr lvl="2" algn="l">
-              <a:spcBef>
-                <a:spcPts val="0"/>
-              </a:spcBef>
-              <a:spcAft>
-                <a:spcPts val="0"/>
-              </a:spcAft>
-              <a:buSzPts val="1400"/>
-              <a:buNone/>
-              <a:defRPr/>
-            </a:lvl3pPr>
-            <a:lvl4pPr lvl="3" algn="l">
-              <a:spcBef>
-                <a:spcPts val="0"/>
-              </a:spcBef>
-              <a:spcAft>
-                <a:spcPts val="0"/>
-              </a:spcAft>
-              <a:buSzPts val="1400"/>
-              <a:buNone/>
-              <a:defRPr/>
-            </a:lvl4pPr>
-            <a:lvl5pPr lvl="4" algn="l">
-              <a:spcBef>
-                <a:spcPts val="0"/>
-              </a:spcBef>
-              <a:spcAft>
-                <a:spcPts val="0"/>
-              </a:spcAft>
-              <a:buSzPts val="1400"/>
-              <a:buNone/>
-              <a:defRPr/>
-            </a:lvl5pPr>
-            <a:lvl6pPr lvl="5" algn="l">
-              <a:spcBef>
-                <a:spcPts val="0"/>
-              </a:spcBef>
-              <a:spcAft>
-                <a:spcPts val="0"/>
-              </a:spcAft>
-              <a:buSzPts val="1400"/>
-              <a:buNone/>
-              <a:defRPr/>
-            </a:lvl6pPr>
-            <a:lvl7pPr lvl="6" algn="l">
-              <a:spcBef>
-                <a:spcPts val="0"/>
-              </a:spcBef>
-              <a:spcAft>
-                <a:spcPts val="0"/>
-              </a:spcAft>
-              <a:buSzPts val="1400"/>
-              <a:buNone/>
-              <a:defRPr/>
-            </a:lvl7pPr>
-            <a:lvl8pPr lvl="7" algn="l">
-              <a:spcBef>
-                <a:spcPts val="0"/>
-              </a:spcBef>
-              <a:spcAft>
-                <a:spcPts val="0"/>
-              </a:spcAft>
-              <a:buSzPts val="1400"/>
-              <a:buNone/>
-              <a:defRPr/>
-            </a:lvl8pPr>
-            <a:lvl9pPr lvl="8" algn="l">
-              <a:spcBef>
-                <a:spcPts val="0"/>
-              </a:spcBef>
-              <a:spcAft>
-                <a:spcPts val="0"/>
-              </a:spcAft>
-              <a:buSzPts val="1400"/>
-              <a:buNone/>
-              <a:defRPr/>
-            </a:lvl9pPr>
-          </a:lstStyle>
-          <a:p>
-            <a:r>
-              <a:rPr lang="en-US" dirty="0"/>
-              <a:t>Proprietary and Confidential Information</a:t>
-            </a:r>
-            <a:endParaRPr dirty="0"/>
-          </a:p>
-        </p:txBody>
-      </p:sp>
     </p:spTree>
     <p:extLst>
       <p:ext uri="{BB962C8B-B14F-4D97-AF65-F5344CB8AC3E}">
@@ -20578,149 +19482,6 @@
               </a:rPr>
               <a:t>Implementing - MVP Stage</a:t>
             </a:r>
-          </a:p>
-        </p:txBody>
-      </p:sp>
-      <p:sp>
-        <p:nvSpPr>
-          <p:cNvPr id="3" name="Google Shape;18;p9">
-            <a:extLst>
-              <a:ext uri="{FF2B5EF4-FFF2-40B4-BE49-F238E27FC236}">
-                <a16:creationId xmlns:a16="http://schemas.microsoft.com/office/drawing/2014/main" id="{7EF92490-8763-C122-9420-8771007CA2FA}"/>
-              </a:ext>
-            </a:extLst>
-          </p:cNvPr>
-          <p:cNvSpPr txBox="1">
-            <a:spLocks noGrp="1"/>
-          </p:cNvSpPr>
-          <p:nvPr>
-            <p:ph type="ftr" idx="11"/>
-          </p:nvPr>
-        </p:nvSpPr>
-        <p:spPr>
-          <a:xfrm>
-            <a:off x="4038600" y="6356350"/>
-            <a:ext cx="4114800" cy="365125"/>
-          </a:xfrm>
-          <a:prstGeom prst="rect">
-            <a:avLst/>
-          </a:prstGeom>
-          <a:noFill/>
-          <a:ln>
-            <a:noFill/>
-          </a:ln>
-        </p:spPr>
-        <p:txBody>
-          <a:bodyPr spcFirstLastPara="1" wrap="square" lIns="91425" tIns="45700" rIns="91425" bIns="45700" anchor="ctr" anchorCtr="0">
-            <a:noAutofit/>
-          </a:bodyPr>
-          <a:lstStyle>
-            <a:lvl1pPr lvl="0" algn="ctr">
-              <a:spcBef>
-                <a:spcPts val="0"/>
-              </a:spcBef>
-              <a:spcAft>
-                <a:spcPts val="0"/>
-              </a:spcAft>
-              <a:buSzPts val="1400"/>
-              <a:buNone/>
-              <a:defRPr/>
-            </a:lvl1pPr>
-            <a:lvl2pPr lvl="1" algn="l">
-              <a:spcBef>
-                <a:spcPts val="0"/>
-              </a:spcBef>
-              <a:spcAft>
-                <a:spcPts val="0"/>
-              </a:spcAft>
-              <a:buSzPts val="1400"/>
-              <a:buNone/>
-              <a:defRPr/>
-            </a:lvl2pPr>
-            <a:lvl3pPr lvl="2" algn="l">
-              <a:spcBef>
-                <a:spcPts val="0"/>
-              </a:spcBef>
-              <a:spcAft>
-                <a:spcPts val="0"/>
-              </a:spcAft>
-              <a:buSzPts val="1400"/>
-              <a:buNone/>
-              <a:defRPr/>
-            </a:lvl3pPr>
-            <a:lvl4pPr lvl="3" algn="l">
-              <a:spcBef>
-                <a:spcPts val="0"/>
-              </a:spcBef>
-              <a:spcAft>
-                <a:spcPts val="0"/>
-              </a:spcAft>
-              <a:buSzPts val="1400"/>
-              <a:buNone/>
-              <a:defRPr/>
-            </a:lvl4pPr>
-            <a:lvl5pPr lvl="4" algn="l">
-              <a:spcBef>
-                <a:spcPts val="0"/>
-              </a:spcBef>
-              <a:spcAft>
-                <a:spcPts val="0"/>
-              </a:spcAft>
-              <a:buSzPts val="1400"/>
-              <a:buNone/>
-              <a:defRPr/>
-            </a:lvl5pPr>
-            <a:lvl6pPr lvl="5" algn="l">
-              <a:spcBef>
-                <a:spcPts val="0"/>
-              </a:spcBef>
-              <a:spcAft>
-                <a:spcPts val="0"/>
-              </a:spcAft>
-              <a:buSzPts val="1400"/>
-              <a:buNone/>
-              <a:defRPr/>
-            </a:lvl6pPr>
-            <a:lvl7pPr lvl="6" algn="l">
-              <a:spcBef>
-                <a:spcPts val="0"/>
-              </a:spcBef>
-              <a:spcAft>
-                <a:spcPts val="0"/>
-              </a:spcAft>
-              <a:buSzPts val="1400"/>
-              <a:buNone/>
-              <a:defRPr/>
-            </a:lvl7pPr>
-            <a:lvl8pPr lvl="7" algn="l">
-              <a:spcBef>
-                <a:spcPts val="0"/>
-              </a:spcBef>
-              <a:spcAft>
-                <a:spcPts val="0"/>
-              </a:spcAft>
-              <a:buSzPts val="1400"/>
-              <a:buNone/>
-              <a:defRPr/>
-            </a:lvl8pPr>
-            <a:lvl9pPr lvl="8" algn="l">
-              <a:spcBef>
-                <a:spcPts val="0"/>
-              </a:spcBef>
-              <a:spcAft>
-                <a:spcPts val="0"/>
-              </a:spcAft>
-              <a:buSzPts val="1400"/>
-              <a:buNone/>
-              <a:defRPr/>
-            </a:lvl9pPr>
-          </a:lstStyle>
-          <a:p>
-            <a:r>
-              <a:rPr lang="en-US" dirty="0"/>
-              <a:t>Proprietary and Confidential Information</a:t>
-            </a:r>
-            <a:endParaRPr dirty="0"/>
           </a:p>
         </p:txBody>
       </p:sp>
@@ -21336,6 +20097,51 @@
           </a:graphicData>
         </a:graphic>
       </p:graphicFrame>
+      <p:sp>
+        <p:nvSpPr>
+          <p:cNvPr id="2" name="TextBox 1">
+            <a:extLst>
+              <a:ext uri="{FF2B5EF4-FFF2-40B4-BE49-F238E27FC236}">
+                <a16:creationId xmlns:a16="http://schemas.microsoft.com/office/drawing/2014/main" id="{DA37AE46-9A21-9F2C-0953-79B2B8C97D2B}"/>
+              </a:ext>
+            </a:extLst>
+          </p:cNvPr>
+          <p:cNvSpPr txBox="1"/>
+          <p:nvPr/>
+        </p:nvSpPr>
+        <p:spPr>
+          <a:xfrm>
+            <a:off x="969319" y="6284748"/>
+            <a:ext cx="7090403" cy="246221"/>
+          </a:xfrm>
+          <a:prstGeom prst="rect">
+            <a:avLst/>
+          </a:prstGeom>
+          <a:noFill/>
+        </p:spPr>
+        <p:txBody>
+          <a:bodyPr wrap="none" rtlCol="0">
+            <a:spAutoFit/>
+          </a:bodyPr>
+          <a:lstStyle/>
+          <a:p>
+            <a:r>
+              <a:rPr lang="en-US" sz="1000" dirty="0"/>
+              <a:t>*See </a:t>
+            </a:r>
+            <a:r>
+              <a:rPr lang="en-US" sz="1000" dirty="0">
+                <a:hlinkClick r:id="rId3"/>
+              </a:rPr>
+              <a:t>SAFe WSJF article</a:t>
+            </a:r>
+            <a:r>
+              <a:rPr lang="en-US" sz="1000" dirty="0"/>
+              <a:t>; scale for each root parameter is 1, 2, 3, 5, 8, 13, 20 (subset of the modified Fibonacci sequence)</a:t>
+            </a:r>
+          </a:p>
+        </p:txBody>
+      </p:sp>
     </p:spTree>
     <p:extLst>
       <p:ext uri="{BB962C8B-B14F-4D97-AF65-F5344CB8AC3E}">
@@ -21665,149 +20471,6 @@
               </a:rPr>
               <a:t>Implementing - MVP Stage</a:t>
             </a:r>
-          </a:p>
-        </p:txBody>
-      </p:sp>
-      <p:sp>
-        <p:nvSpPr>
-          <p:cNvPr id="6" name="Google Shape;18;p9">
-            <a:extLst>
-              <a:ext uri="{FF2B5EF4-FFF2-40B4-BE49-F238E27FC236}">
-                <a16:creationId xmlns:a16="http://schemas.microsoft.com/office/drawing/2014/main" id="{FC3986F6-425A-0514-DE8E-DE31978EAAD1}"/>
-              </a:ext>
-            </a:extLst>
-          </p:cNvPr>
-          <p:cNvSpPr txBox="1">
-            <a:spLocks noGrp="1"/>
-          </p:cNvSpPr>
-          <p:nvPr>
-            <p:ph type="ftr" idx="11"/>
-          </p:nvPr>
-        </p:nvSpPr>
-        <p:spPr>
-          <a:xfrm>
-            <a:off x="4038600" y="6356350"/>
-            <a:ext cx="4114800" cy="365125"/>
-          </a:xfrm>
-          <a:prstGeom prst="rect">
-            <a:avLst/>
-          </a:prstGeom>
-          <a:noFill/>
-          <a:ln>
-            <a:noFill/>
-          </a:ln>
-        </p:spPr>
-        <p:txBody>
-          <a:bodyPr spcFirstLastPara="1" wrap="square" lIns="91425" tIns="45700" rIns="91425" bIns="45700" anchor="ctr" anchorCtr="0">
-            <a:noAutofit/>
-          </a:bodyPr>
-          <a:lstStyle>
-            <a:lvl1pPr lvl="0" algn="ctr">
-              <a:spcBef>
-                <a:spcPts val="0"/>
-              </a:spcBef>
-              <a:spcAft>
-                <a:spcPts val="0"/>
-              </a:spcAft>
-              <a:buSzPts val="1400"/>
-              <a:buNone/>
-              <a:defRPr/>
-            </a:lvl1pPr>
-            <a:lvl2pPr lvl="1" algn="l">
-              <a:spcBef>
-                <a:spcPts val="0"/>
-              </a:spcBef>
-              <a:spcAft>
-                <a:spcPts val="0"/>
-              </a:spcAft>
-              <a:buSzPts val="1400"/>
-              <a:buNone/>
-              <a:defRPr/>
-            </a:lvl2pPr>
-            <a:lvl3pPr lvl="2" algn="l">
-              <a:spcBef>
-                <a:spcPts val="0"/>
-              </a:spcBef>
-              <a:spcAft>
-                <a:spcPts val="0"/>
-              </a:spcAft>
-              <a:buSzPts val="1400"/>
-              <a:buNone/>
-              <a:defRPr/>
-            </a:lvl3pPr>
-            <a:lvl4pPr lvl="3" algn="l">
-              <a:spcBef>
-                <a:spcPts val="0"/>
-              </a:spcBef>
-              <a:spcAft>
-                <a:spcPts val="0"/>
-              </a:spcAft>
-              <a:buSzPts val="1400"/>
-              <a:buNone/>
-              <a:defRPr/>
-            </a:lvl4pPr>
-            <a:lvl5pPr lvl="4" algn="l">
-              <a:spcBef>
-                <a:spcPts val="0"/>
-              </a:spcBef>
-              <a:spcAft>
-                <a:spcPts val="0"/>
-              </a:spcAft>
-              <a:buSzPts val="1400"/>
-              <a:buNone/>
-              <a:defRPr/>
-            </a:lvl5pPr>
-            <a:lvl6pPr lvl="5" algn="l">
-              <a:spcBef>
-                <a:spcPts val="0"/>
-              </a:spcBef>
-              <a:spcAft>
-                <a:spcPts val="0"/>
-              </a:spcAft>
-              <a:buSzPts val="1400"/>
-              <a:buNone/>
-              <a:defRPr/>
-            </a:lvl6pPr>
-            <a:lvl7pPr lvl="6" algn="l">
-              <a:spcBef>
-                <a:spcPts val="0"/>
-              </a:spcBef>
-              <a:spcAft>
-                <a:spcPts val="0"/>
-              </a:spcAft>
-              <a:buSzPts val="1400"/>
-              <a:buNone/>
-              <a:defRPr/>
-            </a:lvl7pPr>
-            <a:lvl8pPr lvl="7" algn="l">
-              <a:spcBef>
-                <a:spcPts val="0"/>
-              </a:spcBef>
-              <a:spcAft>
-                <a:spcPts val="0"/>
-              </a:spcAft>
-              <a:buSzPts val="1400"/>
-              <a:buNone/>
-              <a:defRPr/>
-            </a:lvl8pPr>
-            <a:lvl9pPr lvl="8" algn="l">
-              <a:spcBef>
-                <a:spcPts val="0"/>
-              </a:spcBef>
-              <a:spcAft>
-                <a:spcPts val="0"/>
-              </a:spcAft>
-              <a:buSzPts val="1400"/>
-              <a:buNone/>
-              <a:defRPr/>
-            </a:lvl9pPr>
-          </a:lstStyle>
-          <a:p>
-            <a:r>
-              <a:rPr lang="en-US" dirty="0"/>
-              <a:t>Proprietary and Confidential Information</a:t>
-            </a:r>
-            <a:endParaRPr dirty="0"/>
           </a:p>
         </p:txBody>
       </p:sp>

</xml_diff>